<commit_message>
feat: single-bundle plugin (engine travels with skills) + report figures + contrast gate
- Portability [hi]: marketplace.json now ships ONE bundle plugin (source '.') with a
  root .claude-plugin/plugin.json, so the shared _engine/ is installed together with
  all 23 skills (fixes the risk that a per-skill install loses ../../_engine). README
  install updated to /plugin install kr-brand-decks@kr-brand-decks. validate_marketplace
  updated for the bundle model (asserts _engine present inside the source).
- Reports: Samsung adds a segment revenue+OP table (DS/DX/SDC/Harman, Q1'26 confirmed);
  SK hynix adds a 2025 annual-results reference table. Real sourced figures.
- Quality gate: validate.py --check-contrast gates palette readability (cover text on
  divider bg, eyebrow on white, accent-tick visibility) — would have caught the tick
  bug. Wired into build_all; all 23 palettes pass.

Co-Authored-By: Claude Opus 4.8 <noreply@anthropic.com>
</commit_message>
<xml_diff>
--- a/reports/samsung-2026Q2.pptx
+++ b/reports/samsung-2026Q2.pptx
@@ -18,6 +18,7 @@
     <p:sldId id="266" r:id="rId17"/>
     <p:sldId id="267" r:id="rId18"/>
     <p:sldId id="268" r:id="rId19"/>
+    <p:sldId id="269" r:id="rId20"/>
   </p:sldIdLst>
   <p:sldSz cx="12191695" cy="6858000" type="screen4x3"/>
   <p:notesSz cx="6858000" cy="9144000"/>
@@ -3657,7 +3658,7 @@
                 <a:latin typeface="Pretendard"/>
                 <a:ea typeface="Pretendard"/>
               </a:rPr>
-              <a:t>반도체(DS) 쏠림 구조</a:t>
+              <a:t>부문별 매출·영업이익</a:t>
             </a:r>
           </a:p>
         </p:txBody>
@@ -3703,7 +3704,7 @@
                 <a:latin typeface="Pretendard"/>
                 <a:ea typeface="Pretendard"/>
               </a:rPr>
-              <a:t>메모리 슈퍼사이클로 반도체가 전사 이익을 사실상 전담 (2026년 1분기 확정 기준)</a:t>
+              <a:t>2026년 1분기 확정 기준 (단위: 조원) · 2분기 부문별은 확정실적에서 발표</a:t>
             </a:r>
           </a:p>
         </p:txBody>
@@ -3796,684 +3797,30 @@
           </a:p>
         </p:txBody>
       </p:sp>
-      <p:sp>
-        <p:nvSpPr>
-          <p:cNvPr id="7" name="Rectangle 6"/>
-          <p:cNvSpPr/>
-          <p:nvPr/>
-        </p:nvSpPr>
-        <p:spPr>
-          <a:xfrm>
-            <a:off x="566928" y="2788920"/>
-            <a:ext cx="3444239" cy="2468880"/>
-          </a:xfrm>
-          <a:prstGeom prst="rect">
-            <a:avLst/>
-          </a:prstGeom>
-          <a:solidFill>
-            <a:srgbClr val="F5F6F8"/>
-          </a:solidFill>
-          <a:ln>
-            <a:noFill/>
-          </a:ln>
-          <a:effectLst/>
-        </p:spPr>
-        <p:style>
-          <a:lnRef idx="1">
-            <a:schemeClr val="accent1"/>
-          </a:lnRef>
-          <a:fillRef idx="3">
-            <a:schemeClr val="accent1"/>
-          </a:fillRef>
-          <a:effectRef idx="2">
-            <a:schemeClr val="accent1"/>
-          </a:effectRef>
-          <a:fontRef idx="minor">
-            <a:schemeClr val="lt1"/>
-          </a:fontRef>
-        </p:style>
-        <p:txBody>
-          <a:bodyPr rtlCol="0" anchor="ctr"/>
-          <a:lstStyle/>
-          <a:p>
-            <a:pPr algn="ctr"/>
-          </a:p>
-        </p:txBody>
-      </p:sp>
-      <p:sp>
-        <p:nvSpPr>
-          <p:cNvPr id="8" name="Rectangle 7"/>
-          <p:cNvSpPr/>
-          <p:nvPr/>
-        </p:nvSpPr>
-        <p:spPr>
-          <a:xfrm>
-            <a:off x="566928" y="2788920"/>
-            <a:ext cx="3444239" cy="73152"/>
-          </a:xfrm>
-          <a:prstGeom prst="rect">
-            <a:avLst/>
-          </a:prstGeom>
-          <a:solidFill>
-            <a:srgbClr val="1428A0"/>
-          </a:solidFill>
-          <a:ln>
-            <a:noFill/>
-          </a:ln>
-          <a:effectLst/>
-        </p:spPr>
-        <p:style>
-          <a:lnRef idx="1">
-            <a:schemeClr val="accent1"/>
-          </a:lnRef>
-          <a:fillRef idx="3">
-            <a:schemeClr val="accent1"/>
-          </a:fillRef>
-          <a:effectRef idx="2">
-            <a:schemeClr val="accent1"/>
-          </a:effectRef>
-          <a:fontRef idx="minor">
-            <a:schemeClr val="lt1"/>
-          </a:fontRef>
-        </p:style>
-        <p:txBody>
-          <a:bodyPr rtlCol="0" anchor="ctr"/>
-          <a:lstStyle/>
-          <a:p>
-            <a:pPr algn="ctr"/>
-          </a:p>
-        </p:txBody>
-      </p:sp>
-      <p:sp>
-        <p:nvSpPr>
-          <p:cNvPr id="9" name="TextBox 8"/>
-          <p:cNvSpPr txBox="1"/>
-          <p:nvPr/>
-        </p:nvSpPr>
-        <p:spPr>
-          <a:xfrm>
-            <a:off x="841247" y="3154679"/>
-            <a:ext cx="2895599" cy="365760"/>
-          </a:xfrm>
-          <a:prstGeom prst="rect">
-            <a:avLst/>
-          </a:prstGeom>
-          <a:noFill/>
-        </p:spPr>
-        <p:txBody>
-          <a:bodyPr wrap="square" anchor="t" lIns="0" rIns="0" tIns="0" bIns="0">
-            <a:spAutoFit/>
-          </a:bodyPr>
-          <a:lstStyle/>
-          <a:p>
-            <a:pPr algn="l">
-              <a:lnSpc>
-                <a:spcPct val="115000"/>
-              </a:lnSpc>
-              <a:spcBef>
-                <a:spcPts val="0"/>
-              </a:spcBef>
-              <a:spcAft>
-                <a:spcPts val="0"/>
-              </a:spcAft>
-            </a:pPr>
-            <a:r>
-              <a:rPr sz="1200" b="0">
-                <a:solidFill>
-                  <a:srgbClr val="4A4A4A"/>
-                </a:solidFill>
-                <a:latin typeface="Pretendard"/>
-                <a:ea typeface="Pretendard"/>
-              </a:rPr>
-              <a:t>DS 영업이익 (Q1'26)</a:t>
-            </a:r>
-          </a:p>
-        </p:txBody>
-      </p:sp>
-      <p:sp>
-        <p:nvSpPr>
-          <p:cNvPr id="10" name="TextBox 9"/>
-          <p:cNvSpPr txBox="1"/>
-          <p:nvPr/>
-        </p:nvSpPr>
-        <p:spPr>
-          <a:xfrm>
-            <a:off x="841247" y="3630168"/>
-            <a:ext cx="2895599" cy="914400"/>
-          </a:xfrm>
-          <a:prstGeom prst="rect">
-            <a:avLst/>
-          </a:prstGeom>
-          <a:noFill/>
-        </p:spPr>
-        <p:txBody>
-          <a:bodyPr wrap="square" anchor="t" lIns="0" rIns="0" tIns="0" bIns="0">
-            <a:spAutoFit/>
-          </a:bodyPr>
-          <a:lstStyle/>
-          <a:p>
-            <a:pPr algn="l">
-              <a:lnSpc>
-                <a:spcPct val="115000"/>
-              </a:lnSpc>
-              <a:spcBef>
-                <a:spcPts val="0"/>
-              </a:spcBef>
-              <a:spcAft>
-                <a:spcPts val="0"/>
-              </a:spcAft>
-            </a:pPr>
-            <a:r>
-              <a:rPr sz="3300" b="1">
-                <a:solidFill>
-                  <a:srgbClr val="1A1A1A"/>
-                </a:solidFill>
-                <a:latin typeface="Pretendard"/>
-                <a:ea typeface="Pretendard"/>
-              </a:rPr>
-              <a:t>53.7조원</a:t>
-            </a:r>
-          </a:p>
-        </p:txBody>
-      </p:sp>
-      <p:sp>
-        <p:nvSpPr>
-          <p:cNvPr id="11" name="TextBox 10"/>
-          <p:cNvSpPr txBox="1"/>
-          <p:nvPr/>
-        </p:nvSpPr>
-        <p:spPr>
-          <a:xfrm>
-            <a:off x="841247" y="4690872"/>
-            <a:ext cx="2895599" cy="365760"/>
-          </a:xfrm>
-          <a:prstGeom prst="rect">
-            <a:avLst/>
-          </a:prstGeom>
-          <a:noFill/>
-        </p:spPr>
-        <p:txBody>
-          <a:bodyPr wrap="square" anchor="t" lIns="0" rIns="0" tIns="0" bIns="0">
-            <a:spAutoFit/>
-          </a:bodyPr>
-          <a:lstStyle/>
-          <a:p>
-            <a:pPr algn="l">
-              <a:lnSpc>
-                <a:spcPct val="115000"/>
-              </a:lnSpc>
-              <a:spcBef>
-                <a:spcPts val="0"/>
-              </a:spcBef>
-              <a:spcAft>
-                <a:spcPts val="0"/>
-              </a:spcAft>
-            </a:pPr>
-            <a:r>
-              <a:rPr sz="1250" b="1">
-                <a:solidFill>
-                  <a:srgbClr val="1428A0"/>
-                </a:solidFill>
-                <a:latin typeface="Pretendard"/>
-                <a:ea typeface="Pretendard"/>
-              </a:rPr>
-              <a:t>분기 사상 최대</a:t>
-            </a:r>
-          </a:p>
-        </p:txBody>
-      </p:sp>
-      <p:sp>
-        <p:nvSpPr>
-          <p:cNvPr id="12" name="Rectangle 11"/>
-          <p:cNvSpPr/>
-          <p:nvPr/>
-        </p:nvSpPr>
-        <p:spPr>
-          <a:xfrm>
-            <a:off x="4376928" y="2788920"/>
-            <a:ext cx="3444239" cy="2468880"/>
-          </a:xfrm>
-          <a:prstGeom prst="rect">
-            <a:avLst/>
-          </a:prstGeom>
-          <a:solidFill>
-            <a:srgbClr val="F5F6F8"/>
-          </a:solidFill>
-          <a:ln>
-            <a:noFill/>
-          </a:ln>
-          <a:effectLst/>
-        </p:spPr>
-        <p:style>
-          <a:lnRef idx="1">
-            <a:schemeClr val="accent1"/>
-          </a:lnRef>
-          <a:fillRef idx="3">
-            <a:schemeClr val="accent1"/>
-          </a:fillRef>
-          <a:effectRef idx="2">
-            <a:schemeClr val="accent1"/>
-          </a:effectRef>
-          <a:fontRef idx="minor">
-            <a:schemeClr val="lt1"/>
-          </a:fontRef>
-        </p:style>
-        <p:txBody>
-          <a:bodyPr rtlCol="0" anchor="ctr"/>
-          <a:lstStyle/>
-          <a:p>
-            <a:pPr algn="ctr"/>
-          </a:p>
-        </p:txBody>
-      </p:sp>
-      <p:sp>
-        <p:nvSpPr>
-          <p:cNvPr id="13" name="Rectangle 12"/>
-          <p:cNvSpPr/>
-          <p:nvPr/>
-        </p:nvSpPr>
-        <p:spPr>
-          <a:xfrm>
-            <a:off x="4376928" y="2788920"/>
-            <a:ext cx="3444239" cy="73152"/>
-          </a:xfrm>
-          <a:prstGeom prst="rect">
-            <a:avLst/>
-          </a:prstGeom>
-          <a:solidFill>
-            <a:srgbClr val="1428A0"/>
-          </a:solidFill>
-          <a:ln>
-            <a:noFill/>
-          </a:ln>
-          <a:effectLst/>
-        </p:spPr>
-        <p:style>
-          <a:lnRef idx="1">
-            <a:schemeClr val="accent1"/>
-          </a:lnRef>
-          <a:fillRef idx="3">
-            <a:schemeClr val="accent1"/>
-          </a:fillRef>
-          <a:effectRef idx="2">
-            <a:schemeClr val="accent1"/>
-          </a:effectRef>
-          <a:fontRef idx="minor">
-            <a:schemeClr val="lt1"/>
-          </a:fontRef>
-        </p:style>
-        <p:txBody>
-          <a:bodyPr rtlCol="0" anchor="ctr"/>
-          <a:lstStyle/>
-          <a:p>
-            <a:pPr algn="ctr"/>
-          </a:p>
-        </p:txBody>
-      </p:sp>
-      <p:sp>
-        <p:nvSpPr>
-          <p:cNvPr id="14" name="TextBox 13"/>
-          <p:cNvSpPr txBox="1"/>
-          <p:nvPr/>
-        </p:nvSpPr>
-        <p:spPr>
-          <a:xfrm>
-            <a:off x="4651247" y="3154679"/>
-            <a:ext cx="2895599" cy="365760"/>
-          </a:xfrm>
-          <a:prstGeom prst="rect">
-            <a:avLst/>
-          </a:prstGeom>
-          <a:noFill/>
-        </p:spPr>
-        <p:txBody>
-          <a:bodyPr wrap="square" anchor="t" lIns="0" rIns="0" tIns="0" bIns="0">
-            <a:spAutoFit/>
-          </a:bodyPr>
-          <a:lstStyle/>
-          <a:p>
-            <a:pPr algn="l">
-              <a:lnSpc>
-                <a:spcPct val="115000"/>
-              </a:lnSpc>
-              <a:spcBef>
-                <a:spcPts val="0"/>
-              </a:spcBef>
-              <a:spcAft>
-                <a:spcPts val="0"/>
-              </a:spcAft>
-            </a:pPr>
-            <a:r>
-              <a:rPr sz="1200" b="0">
-                <a:solidFill>
-                  <a:srgbClr val="4A4A4A"/>
-                </a:solidFill>
-                <a:latin typeface="Pretendard"/>
-                <a:ea typeface="Pretendard"/>
-              </a:rPr>
-              <a:t>전사 영업이익 중 DS 비중</a:t>
-            </a:r>
-          </a:p>
-        </p:txBody>
-      </p:sp>
-      <p:sp>
-        <p:nvSpPr>
-          <p:cNvPr id="15" name="TextBox 14"/>
-          <p:cNvSpPr txBox="1"/>
-          <p:nvPr/>
-        </p:nvSpPr>
-        <p:spPr>
-          <a:xfrm>
-            <a:off x="4651247" y="3630168"/>
-            <a:ext cx="2895599" cy="914400"/>
-          </a:xfrm>
-          <a:prstGeom prst="rect">
-            <a:avLst/>
-          </a:prstGeom>
-          <a:noFill/>
-        </p:spPr>
-        <p:txBody>
-          <a:bodyPr wrap="square" anchor="t" lIns="0" rIns="0" tIns="0" bIns="0">
-            <a:spAutoFit/>
-          </a:bodyPr>
-          <a:lstStyle/>
-          <a:p>
-            <a:pPr algn="l">
-              <a:lnSpc>
-                <a:spcPct val="115000"/>
-              </a:lnSpc>
-              <a:spcBef>
-                <a:spcPts val="0"/>
-              </a:spcBef>
-              <a:spcAft>
-                <a:spcPts val="0"/>
-              </a:spcAft>
-            </a:pPr>
-            <a:r>
-              <a:rPr sz="3300" b="1">
-                <a:solidFill>
-                  <a:srgbClr val="1A1A1A"/>
-                </a:solidFill>
-                <a:latin typeface="Pretendard"/>
-                <a:ea typeface="Pretendard"/>
-              </a:rPr>
-              <a:t>약 94%</a:t>
-            </a:r>
-          </a:p>
-        </p:txBody>
-      </p:sp>
-      <p:sp>
-        <p:nvSpPr>
-          <p:cNvPr id="16" name="TextBox 15"/>
-          <p:cNvSpPr txBox="1"/>
-          <p:nvPr/>
-        </p:nvSpPr>
-        <p:spPr>
-          <a:xfrm>
-            <a:off x="4651247" y="4690872"/>
-            <a:ext cx="2895599" cy="365760"/>
-          </a:xfrm>
-          <a:prstGeom prst="rect">
-            <a:avLst/>
-          </a:prstGeom>
-          <a:noFill/>
-        </p:spPr>
-        <p:txBody>
-          <a:bodyPr wrap="square" anchor="t" lIns="0" rIns="0" tIns="0" bIns="0">
-            <a:spAutoFit/>
-          </a:bodyPr>
-          <a:lstStyle/>
-          <a:p>
-            <a:pPr algn="l">
-              <a:lnSpc>
-                <a:spcPct val="115000"/>
-              </a:lnSpc>
-              <a:spcBef>
-                <a:spcPts val="0"/>
-              </a:spcBef>
-              <a:spcAft>
-                <a:spcPts val="0"/>
-              </a:spcAft>
-            </a:pPr>
-            <a:r>
-              <a:rPr sz="1250" b="1">
-                <a:solidFill>
-                  <a:srgbClr val="1428A0"/>
-                </a:solidFill>
-                <a:latin typeface="Pretendard"/>
-                <a:ea typeface="Pretendard"/>
-              </a:rPr>
-              <a:t>메모리·HBM 견인</a:t>
-            </a:r>
-          </a:p>
-        </p:txBody>
-      </p:sp>
-      <p:sp>
-        <p:nvSpPr>
-          <p:cNvPr id="17" name="Rectangle 16"/>
-          <p:cNvSpPr/>
-          <p:nvPr/>
-        </p:nvSpPr>
-        <p:spPr>
-          <a:xfrm>
-            <a:off x="8186927" y="2788920"/>
-            <a:ext cx="3444239" cy="2468880"/>
-          </a:xfrm>
-          <a:prstGeom prst="rect">
-            <a:avLst/>
-          </a:prstGeom>
-          <a:solidFill>
-            <a:srgbClr val="F5F6F8"/>
-          </a:solidFill>
-          <a:ln>
-            <a:noFill/>
-          </a:ln>
-          <a:effectLst/>
-        </p:spPr>
-        <p:style>
-          <a:lnRef idx="1">
-            <a:schemeClr val="accent1"/>
-          </a:lnRef>
-          <a:fillRef idx="3">
-            <a:schemeClr val="accent1"/>
-          </a:fillRef>
-          <a:effectRef idx="2">
-            <a:schemeClr val="accent1"/>
-          </a:effectRef>
-          <a:fontRef idx="minor">
-            <a:schemeClr val="lt1"/>
-          </a:fontRef>
-        </p:style>
-        <p:txBody>
-          <a:bodyPr rtlCol="0" anchor="ctr"/>
-          <a:lstStyle/>
-          <a:p>
-            <a:pPr algn="ctr"/>
-          </a:p>
-        </p:txBody>
-      </p:sp>
-      <p:sp>
-        <p:nvSpPr>
-          <p:cNvPr id="18" name="Rectangle 17"/>
-          <p:cNvSpPr/>
-          <p:nvPr/>
-        </p:nvSpPr>
-        <p:spPr>
-          <a:xfrm>
-            <a:off x="8186927" y="2788920"/>
-            <a:ext cx="3444239" cy="73152"/>
-          </a:xfrm>
-          <a:prstGeom prst="rect">
-            <a:avLst/>
-          </a:prstGeom>
-          <a:solidFill>
-            <a:srgbClr val="1428A0"/>
-          </a:solidFill>
-          <a:ln>
-            <a:noFill/>
-          </a:ln>
-          <a:effectLst/>
-        </p:spPr>
-        <p:style>
-          <a:lnRef idx="1">
-            <a:schemeClr val="accent1"/>
-          </a:lnRef>
-          <a:fillRef idx="3">
-            <a:schemeClr val="accent1"/>
-          </a:fillRef>
-          <a:effectRef idx="2">
-            <a:schemeClr val="accent1"/>
-          </a:effectRef>
-          <a:fontRef idx="minor">
-            <a:schemeClr val="lt1"/>
-          </a:fontRef>
-        </p:style>
-        <p:txBody>
-          <a:bodyPr rtlCol="0" anchor="ctr"/>
-          <a:lstStyle/>
-          <a:p>
-            <a:pPr algn="ctr"/>
-          </a:p>
-        </p:txBody>
-      </p:sp>
-      <p:sp>
-        <p:nvSpPr>
-          <p:cNvPr id="19" name="TextBox 18"/>
-          <p:cNvSpPr txBox="1"/>
-          <p:nvPr/>
-        </p:nvSpPr>
-        <p:spPr>
-          <a:xfrm>
-            <a:off x="8461247" y="3154679"/>
-            <a:ext cx="2895599" cy="365760"/>
-          </a:xfrm>
-          <a:prstGeom prst="rect">
-            <a:avLst/>
-          </a:prstGeom>
-          <a:noFill/>
-        </p:spPr>
-        <p:txBody>
-          <a:bodyPr wrap="square" anchor="t" lIns="0" rIns="0" tIns="0" bIns="0">
-            <a:spAutoFit/>
-          </a:bodyPr>
-          <a:lstStyle/>
-          <a:p>
-            <a:pPr algn="l">
-              <a:lnSpc>
-                <a:spcPct val="115000"/>
-              </a:lnSpc>
-              <a:spcBef>
-                <a:spcPts val="0"/>
-              </a:spcBef>
-              <a:spcAft>
-                <a:spcPts val="0"/>
-              </a:spcAft>
-            </a:pPr>
-            <a:r>
-              <a:rPr sz="1200" b="0">
-                <a:solidFill>
-                  <a:srgbClr val="4A4A4A"/>
-                </a:solidFill>
-                <a:latin typeface="Pretendard"/>
-                <a:ea typeface="Pretendard"/>
-              </a:rPr>
-              <a:t>DX 영업이익 (Q1'26)</a:t>
-            </a:r>
-          </a:p>
-        </p:txBody>
-      </p:sp>
-      <p:sp>
-        <p:nvSpPr>
-          <p:cNvPr id="20" name="TextBox 19"/>
-          <p:cNvSpPr txBox="1"/>
-          <p:nvPr/>
-        </p:nvSpPr>
-        <p:spPr>
-          <a:xfrm>
-            <a:off x="8461247" y="3630168"/>
-            <a:ext cx="2895599" cy="914400"/>
-          </a:xfrm>
-          <a:prstGeom prst="rect">
-            <a:avLst/>
-          </a:prstGeom>
-          <a:noFill/>
-        </p:spPr>
-        <p:txBody>
-          <a:bodyPr wrap="square" anchor="t" lIns="0" rIns="0" tIns="0" bIns="0">
-            <a:spAutoFit/>
-          </a:bodyPr>
-          <a:lstStyle/>
-          <a:p>
-            <a:pPr algn="l">
-              <a:lnSpc>
-                <a:spcPct val="115000"/>
-              </a:lnSpc>
-              <a:spcBef>
-                <a:spcPts val="0"/>
-              </a:spcBef>
-              <a:spcAft>
-                <a:spcPts val="0"/>
-              </a:spcAft>
-            </a:pPr>
-            <a:r>
-              <a:rPr sz="3300" b="1">
-                <a:solidFill>
-                  <a:srgbClr val="1A1A1A"/>
-                </a:solidFill>
-                <a:latin typeface="Pretendard"/>
-                <a:ea typeface="Pretendard"/>
-              </a:rPr>
-              <a:t>3.0조원</a:t>
-            </a:r>
-          </a:p>
-        </p:txBody>
-      </p:sp>
-      <p:sp>
-        <p:nvSpPr>
-          <p:cNvPr id="21" name="TextBox 20"/>
-          <p:cNvSpPr txBox="1"/>
-          <p:nvPr/>
-        </p:nvSpPr>
-        <p:spPr>
-          <a:xfrm>
-            <a:off x="8461247" y="4690872"/>
-            <a:ext cx="2895599" cy="365760"/>
-          </a:xfrm>
-          <a:prstGeom prst="rect">
-            <a:avLst/>
-          </a:prstGeom>
-          <a:noFill/>
-        </p:spPr>
-        <p:txBody>
-          <a:bodyPr wrap="square" anchor="t" lIns="0" rIns="0" tIns="0" bIns="0">
-            <a:spAutoFit/>
-          </a:bodyPr>
-          <a:lstStyle/>
-          <a:p>
-            <a:pPr algn="l">
-              <a:lnSpc>
-                <a:spcPct val="115000"/>
-              </a:lnSpc>
-              <a:spcBef>
-                <a:spcPts val="0"/>
-              </a:spcBef>
-              <a:spcAft>
-                <a:spcPts val="0"/>
-              </a:spcAft>
-            </a:pPr>
-            <a:r>
-              <a:rPr sz="1250" b="1">
-                <a:solidFill>
-                  <a:srgbClr val="1428A0"/>
-                </a:solidFill>
-                <a:latin typeface="Pretendard"/>
-                <a:ea typeface="Pretendard"/>
-              </a:rPr>
-              <a:t>메모리 원가 부담</a:t>
-            </a:r>
-          </a:p>
-        </p:txBody>
-      </p:sp>
+      <p:pic>
+        <p:nvPicPr>
+          <p:cNvPr id="7" name="Picture 6" descr="table_5.png"/>
+          <p:cNvPicPr>
+            <a:picLocks noChangeAspect="1"/>
+          </p:cNvPicPr>
+          <p:nvPr/>
+        </p:nvPicPr>
+        <p:blipFill>
+          <a:blip r:embed="rId2"/>
+          <a:stretch>
+            <a:fillRect/>
+          </a:stretch>
+        </p:blipFill>
+        <p:spPr>
+          <a:xfrm>
+            <a:off x="1949252" y="2468880"/>
+            <a:ext cx="8299591" cy="3657600"/>
+          </a:xfrm>
+          <a:prstGeom prst="rect">
+            <a:avLst/>
+          </a:prstGeom>
+        </p:spPr>
+      </p:pic>
     </p:spTree>
   </p:cSld>
   <p:clrMapOvr>
@@ -4541,7 +3888,7 @@
                 <a:latin typeface="Pretendard"/>
                 <a:ea typeface="Pretendard"/>
               </a:rPr>
-              <a:t>05 · 사업 현황 · 전망</a:t>
+              <a:t>04 · 사업 부문</a:t>
             </a:r>
           </a:p>
         </p:txBody>
@@ -4587,7 +3934,7 @@
                 <a:latin typeface="Pretendard"/>
                 <a:ea typeface="Pretendard"/>
               </a:rPr>
-              <a:t>핵심 하이라이트 · 전망</a:t>
+              <a:t>반도체(DS) 쏠림 구조</a:t>
             </a:r>
           </a:p>
         </p:txBody>
@@ -4633,7 +3980,7 @@
                 <a:latin typeface="Pretendard"/>
                 <a:ea typeface="Pretendard"/>
               </a:rPr>
-              <a:t>AI 서버 수요가 메모리 실적 급증을 견인</a:t>
+              <a:t>메모리 슈퍼사이클로 반도체가 전사 이익을 사실상 전담 (2026년 1분기 확정 기준)</a:t>
             </a:r>
           </a:p>
         </p:txBody>
@@ -4728,60 +4075,102 @@
       </p:sp>
       <p:sp>
         <p:nvSpPr>
-          <p:cNvPr id="7" name="TextBox 6"/>
+          <p:cNvPr id="7" name="Rectangle 6"/>
+          <p:cNvSpPr/>
+          <p:nvPr/>
+        </p:nvSpPr>
+        <p:spPr>
+          <a:xfrm>
+            <a:off x="566928" y="2788920"/>
+            <a:ext cx="3444239" cy="2468880"/>
+          </a:xfrm>
+          <a:prstGeom prst="rect">
+            <a:avLst/>
+          </a:prstGeom>
+          <a:solidFill>
+            <a:srgbClr val="F5F6F8"/>
+          </a:solidFill>
+          <a:ln>
+            <a:noFill/>
+          </a:ln>
+          <a:effectLst/>
+        </p:spPr>
+        <p:style>
+          <a:lnRef idx="1">
+            <a:schemeClr val="accent1"/>
+          </a:lnRef>
+          <a:fillRef idx="3">
+            <a:schemeClr val="accent1"/>
+          </a:fillRef>
+          <a:effectRef idx="2">
+            <a:schemeClr val="accent1"/>
+          </a:effectRef>
+          <a:fontRef idx="minor">
+            <a:schemeClr val="lt1"/>
+          </a:fontRef>
+        </p:style>
+        <p:txBody>
+          <a:bodyPr rtlCol="0" anchor="ctr"/>
+          <a:lstStyle/>
+          <a:p>
+            <a:pPr algn="ctr"/>
+          </a:p>
+        </p:txBody>
+      </p:sp>
+      <p:sp>
+        <p:nvSpPr>
+          <p:cNvPr id="8" name="Rectangle 7"/>
+          <p:cNvSpPr/>
+          <p:nvPr/>
+        </p:nvSpPr>
+        <p:spPr>
+          <a:xfrm>
+            <a:off x="566928" y="2788920"/>
+            <a:ext cx="3444239" cy="73152"/>
+          </a:xfrm>
+          <a:prstGeom prst="rect">
+            <a:avLst/>
+          </a:prstGeom>
+          <a:solidFill>
+            <a:srgbClr val="1428A0"/>
+          </a:solidFill>
+          <a:ln>
+            <a:noFill/>
+          </a:ln>
+          <a:effectLst/>
+        </p:spPr>
+        <p:style>
+          <a:lnRef idx="1">
+            <a:schemeClr val="accent1"/>
+          </a:lnRef>
+          <a:fillRef idx="3">
+            <a:schemeClr val="accent1"/>
+          </a:fillRef>
+          <a:effectRef idx="2">
+            <a:schemeClr val="accent1"/>
+          </a:effectRef>
+          <a:fontRef idx="minor">
+            <a:schemeClr val="lt1"/>
+          </a:fontRef>
+        </p:style>
+        <p:txBody>
+          <a:bodyPr rtlCol="0" anchor="ctr"/>
+          <a:lstStyle/>
+          <a:p>
+            <a:pPr algn="ctr"/>
+          </a:p>
+        </p:txBody>
+      </p:sp>
+      <p:sp>
+        <p:nvSpPr>
+          <p:cNvPr id="9" name="TextBox 8"/>
           <p:cNvSpPr txBox="1"/>
           <p:nvPr/>
         </p:nvSpPr>
         <p:spPr>
           <a:xfrm>
-            <a:off x="566928" y="2697480"/>
-            <a:ext cx="3017520" cy="3291840"/>
-          </a:xfrm>
-          <a:prstGeom prst="rect">
-            <a:avLst/>
-          </a:prstGeom>
-          <a:noFill/>
-        </p:spPr>
-        <p:txBody>
-          <a:bodyPr wrap="square" anchor="t" lIns="0" rIns="0" tIns="0" bIns="0">
-            <a:spAutoFit/>
-          </a:bodyPr>
-          <a:lstStyle/>
-          <a:p>
-            <a:pPr algn="l">
-              <a:lnSpc>
-                <a:spcPct val="150000"/>
-              </a:lnSpc>
-              <a:spcBef>
-                <a:spcPts val="0"/>
-              </a:spcBef>
-              <a:spcAft>
-                <a:spcPts val="0"/>
-              </a:spcAft>
-            </a:pPr>
-            <a:r>
-              <a:rPr sz="1250" b="0">
-                <a:solidFill>
-                  <a:srgbClr val="4A4A4A"/>
-                </a:solidFill>
-                <a:latin typeface="Pretendard"/>
-                <a:ea typeface="Pretendard"/>
-              </a:rPr>
-              <a:t>HBM·서버 D램·SSD 수요 확대와 메모리 가격 상승이 실적을 이끌었습니다.</a:t>
-            </a:r>
-          </a:p>
-        </p:txBody>
-      </p:sp>
-      <p:sp>
-        <p:nvSpPr>
-          <p:cNvPr id="8" name="TextBox 7"/>
-          <p:cNvSpPr txBox="1"/>
-          <p:nvPr/>
-        </p:nvSpPr>
-        <p:spPr>
-          <a:xfrm>
-            <a:off x="4023360" y="2651760"/>
-            <a:ext cx="868680" cy="548640"/>
+            <a:off x="841247" y="3154679"/>
+            <a:ext cx="2895599" cy="365760"/>
           </a:xfrm>
           <a:prstGeom prst="rect">
             <a:avLst/>
@@ -4806,28 +4195,28 @@
               </a:spcAft>
             </a:pPr>
             <a:r>
-              <a:rPr sz="2100" b="1">
-                <a:solidFill>
-                  <a:srgbClr val="1428A0"/>
+              <a:rPr sz="1200" b="0">
+                <a:solidFill>
+                  <a:srgbClr val="4A4A4A"/>
                 </a:solidFill>
                 <a:latin typeface="Pretendard"/>
                 <a:ea typeface="Pretendard"/>
               </a:rPr>
-              <a:t>01</a:t>
-            </a:r>
-          </a:p>
-        </p:txBody>
-      </p:sp>
-      <p:sp>
-        <p:nvSpPr>
-          <p:cNvPr id="9" name="TextBox 8"/>
+              <a:t>DS 영업이익 (Q1'26)</a:t>
+            </a:r>
+          </a:p>
+        </p:txBody>
+      </p:sp>
+      <p:sp>
+        <p:nvSpPr>
+          <p:cNvPr id="10" name="TextBox 9"/>
           <p:cNvSpPr txBox="1"/>
           <p:nvPr/>
         </p:nvSpPr>
         <p:spPr>
           <a:xfrm>
-            <a:off x="4937760" y="2651760"/>
-            <a:ext cx="6675119" cy="384048"/>
+            <a:off x="841247" y="3630168"/>
+            <a:ext cx="2895599" cy="914400"/>
           </a:xfrm>
           <a:prstGeom prst="rect">
             <a:avLst/>
@@ -4852,60 +4241,14 @@
               </a:spcAft>
             </a:pPr>
             <a:r>
-              <a:rPr sz="1400" b="1">
+              <a:rPr sz="3300" b="1">
                 <a:solidFill>
                   <a:srgbClr val="1A1A1A"/>
                 </a:solidFill>
                 <a:latin typeface="Pretendard"/>
                 <a:ea typeface="Pretendard"/>
               </a:rPr>
-              <a:t>메모리 슈퍼사이클</a:t>
-            </a:r>
-          </a:p>
-        </p:txBody>
-      </p:sp>
-      <p:sp>
-        <p:nvSpPr>
-          <p:cNvPr id="10" name="TextBox 9"/>
-          <p:cNvSpPr txBox="1"/>
-          <p:nvPr/>
-        </p:nvSpPr>
-        <p:spPr>
-          <a:xfrm>
-            <a:off x="4937760" y="3035808"/>
-            <a:ext cx="6675119" cy="422910"/>
-          </a:xfrm>
-          <a:prstGeom prst="rect">
-            <a:avLst/>
-          </a:prstGeom>
-          <a:noFill/>
-        </p:spPr>
-        <p:txBody>
-          <a:bodyPr wrap="square" anchor="t" lIns="0" rIns="0" tIns="0" bIns="0">
-            <a:spAutoFit/>
-          </a:bodyPr>
-          <a:lstStyle/>
-          <a:p>
-            <a:pPr algn="l">
-              <a:lnSpc>
-                <a:spcPct val="132000"/>
-              </a:lnSpc>
-              <a:spcBef>
-                <a:spcPts val="0"/>
-              </a:spcBef>
-              <a:spcAft>
-                <a:spcPts val="0"/>
-              </a:spcAft>
-            </a:pPr>
-            <a:r>
-              <a:rPr sz="1150" b="0">
-                <a:solidFill>
-                  <a:srgbClr val="4A4A4A"/>
-                </a:solidFill>
-                <a:latin typeface="Pretendard"/>
-                <a:ea typeface="Pretendard"/>
-              </a:rPr>
-              <a:t>AI 서버향 HBM·D램·SSD 수요와 가격 상승이 실적 급증의 핵심 동인.</a:t>
+              <a:t>53.7조원</a:t>
             </a:r>
           </a:p>
         </p:txBody>
@@ -4918,8 +4261,8 @@
         </p:nvSpPr>
         <p:spPr>
           <a:xfrm>
-            <a:off x="4023360" y="3531870"/>
-            <a:ext cx="868680" cy="548640"/>
+            <a:off x="841247" y="4690872"/>
+            <a:ext cx="2895599" cy="365760"/>
           </a:xfrm>
           <a:prstGeom prst="rect">
             <a:avLst/>
@@ -4944,28 +4287,116 @@
               </a:spcAft>
             </a:pPr>
             <a:r>
-              <a:rPr sz="2100" b="1">
+              <a:rPr sz="1250" b="1">
                 <a:solidFill>
                   <a:srgbClr val="1428A0"/>
                 </a:solidFill>
                 <a:latin typeface="Pretendard"/>
                 <a:ea typeface="Pretendard"/>
               </a:rPr>
-              <a:t>02</a:t>
-            </a:r>
-          </a:p>
-        </p:txBody>
-      </p:sp>
-      <p:sp>
-        <p:nvSpPr>
-          <p:cNvPr id="12" name="TextBox 11"/>
+              <a:t>분기 사상 최대</a:t>
+            </a:r>
+          </a:p>
+        </p:txBody>
+      </p:sp>
+      <p:sp>
+        <p:nvSpPr>
+          <p:cNvPr id="12" name="Rectangle 11"/>
+          <p:cNvSpPr/>
+          <p:nvPr/>
+        </p:nvSpPr>
+        <p:spPr>
+          <a:xfrm>
+            <a:off x="4376928" y="2788920"/>
+            <a:ext cx="3444239" cy="2468880"/>
+          </a:xfrm>
+          <a:prstGeom prst="rect">
+            <a:avLst/>
+          </a:prstGeom>
+          <a:solidFill>
+            <a:srgbClr val="F5F6F8"/>
+          </a:solidFill>
+          <a:ln>
+            <a:noFill/>
+          </a:ln>
+          <a:effectLst/>
+        </p:spPr>
+        <p:style>
+          <a:lnRef idx="1">
+            <a:schemeClr val="accent1"/>
+          </a:lnRef>
+          <a:fillRef idx="3">
+            <a:schemeClr val="accent1"/>
+          </a:fillRef>
+          <a:effectRef idx="2">
+            <a:schemeClr val="accent1"/>
+          </a:effectRef>
+          <a:fontRef idx="minor">
+            <a:schemeClr val="lt1"/>
+          </a:fontRef>
+        </p:style>
+        <p:txBody>
+          <a:bodyPr rtlCol="0" anchor="ctr"/>
+          <a:lstStyle/>
+          <a:p>
+            <a:pPr algn="ctr"/>
+          </a:p>
+        </p:txBody>
+      </p:sp>
+      <p:sp>
+        <p:nvSpPr>
+          <p:cNvPr id="13" name="Rectangle 12"/>
+          <p:cNvSpPr/>
+          <p:nvPr/>
+        </p:nvSpPr>
+        <p:spPr>
+          <a:xfrm>
+            <a:off x="4376928" y="2788920"/>
+            <a:ext cx="3444239" cy="73152"/>
+          </a:xfrm>
+          <a:prstGeom prst="rect">
+            <a:avLst/>
+          </a:prstGeom>
+          <a:solidFill>
+            <a:srgbClr val="1428A0"/>
+          </a:solidFill>
+          <a:ln>
+            <a:noFill/>
+          </a:ln>
+          <a:effectLst/>
+        </p:spPr>
+        <p:style>
+          <a:lnRef idx="1">
+            <a:schemeClr val="accent1"/>
+          </a:lnRef>
+          <a:fillRef idx="3">
+            <a:schemeClr val="accent1"/>
+          </a:fillRef>
+          <a:effectRef idx="2">
+            <a:schemeClr val="accent1"/>
+          </a:effectRef>
+          <a:fontRef idx="minor">
+            <a:schemeClr val="lt1"/>
+          </a:fontRef>
+        </p:style>
+        <p:txBody>
+          <a:bodyPr rtlCol="0" anchor="ctr"/>
+          <a:lstStyle/>
+          <a:p>
+            <a:pPr algn="ctr"/>
+          </a:p>
+        </p:txBody>
+      </p:sp>
+      <p:sp>
+        <p:nvSpPr>
+          <p:cNvPr id="14" name="TextBox 13"/>
           <p:cNvSpPr txBox="1"/>
           <p:nvPr/>
         </p:nvSpPr>
         <p:spPr>
           <a:xfrm>
-            <a:off x="4937760" y="3531870"/>
-            <a:ext cx="6675119" cy="384048"/>
+            <a:off x="4651247" y="3154679"/>
+            <a:ext cx="2895599" cy="365760"/>
           </a:xfrm>
           <a:prstGeom prst="rect">
             <a:avLst/>
@@ -4990,74 +4421,28 @@
               </a:spcAft>
             </a:pPr>
             <a:r>
-              <a:rPr sz="1400" b="1">
-                <a:solidFill>
-                  <a:srgbClr val="1A1A1A"/>
+              <a:rPr sz="1200" b="0">
+                <a:solidFill>
+                  <a:srgbClr val="4A4A4A"/>
                 </a:solidFill>
                 <a:latin typeface="Pretendard"/>
                 <a:ea typeface="Pretendard"/>
               </a:rPr>
-              <a:t>반도체(DS) 견인</a:t>
-            </a:r>
-          </a:p>
-        </p:txBody>
-      </p:sp>
-      <p:sp>
-        <p:nvSpPr>
-          <p:cNvPr id="13" name="TextBox 12"/>
+              <a:t>전사 영업이익 중 DS 비중</a:t>
+            </a:r>
+          </a:p>
+        </p:txBody>
+      </p:sp>
+      <p:sp>
+        <p:nvSpPr>
+          <p:cNvPr id="15" name="TextBox 14"/>
           <p:cNvSpPr txBox="1"/>
           <p:nvPr/>
         </p:nvSpPr>
         <p:spPr>
           <a:xfrm>
-            <a:off x="4937760" y="3915918"/>
-            <a:ext cx="6675119" cy="422910"/>
-          </a:xfrm>
-          <a:prstGeom prst="rect">
-            <a:avLst/>
-          </a:prstGeom>
-          <a:noFill/>
-        </p:spPr>
-        <p:txBody>
-          <a:bodyPr wrap="square" anchor="t" lIns="0" rIns="0" tIns="0" bIns="0">
-            <a:spAutoFit/>
-          </a:bodyPr>
-          <a:lstStyle/>
-          <a:p>
-            <a:pPr algn="l">
-              <a:lnSpc>
-                <a:spcPct val="132000"/>
-              </a:lnSpc>
-              <a:spcBef>
-                <a:spcPts val="0"/>
-              </a:spcBef>
-              <a:spcAft>
-                <a:spcPts val="0"/>
-              </a:spcAft>
-            </a:pPr>
-            <a:r>
-              <a:rPr sz="1150" b="0">
-                <a:solidFill>
-                  <a:srgbClr val="4A4A4A"/>
-                </a:solidFill>
-                <a:latin typeface="Pretendard"/>
-                <a:ea typeface="Pretendard"/>
-              </a:rPr>
-              <a:t>DS 부문이 전사 영업이익의 대부분을 차지, 이익 쏠림이 심화.</a:t>
-            </a:r>
-          </a:p>
-        </p:txBody>
-      </p:sp>
-      <p:sp>
-        <p:nvSpPr>
-          <p:cNvPr id="14" name="TextBox 13"/>
-          <p:cNvSpPr txBox="1"/>
-          <p:nvPr/>
-        </p:nvSpPr>
-        <p:spPr>
-          <a:xfrm>
-            <a:off x="4023360" y="4411980"/>
-            <a:ext cx="868680" cy="548640"/>
+            <a:off x="4651247" y="3630168"/>
+            <a:ext cx="2895599" cy="914400"/>
           </a:xfrm>
           <a:prstGeom prst="rect">
             <a:avLst/>
@@ -5082,28 +4467,28 @@
               </a:spcAft>
             </a:pPr>
             <a:r>
-              <a:rPr sz="2100" b="1">
-                <a:solidFill>
-                  <a:srgbClr val="1428A0"/>
+              <a:rPr sz="3300" b="1">
+                <a:solidFill>
+                  <a:srgbClr val="1A1A1A"/>
                 </a:solidFill>
                 <a:latin typeface="Pretendard"/>
                 <a:ea typeface="Pretendard"/>
               </a:rPr>
-              <a:t>03</a:t>
-            </a:r>
-          </a:p>
-        </p:txBody>
-      </p:sp>
-      <p:sp>
-        <p:nvSpPr>
-          <p:cNvPr id="15" name="TextBox 14"/>
+              <a:t>약 94%</a:t>
+            </a:r>
+          </a:p>
+        </p:txBody>
+      </p:sp>
+      <p:sp>
+        <p:nvSpPr>
+          <p:cNvPr id="16" name="TextBox 15"/>
           <p:cNvSpPr txBox="1"/>
           <p:nvPr/>
         </p:nvSpPr>
         <p:spPr>
           <a:xfrm>
-            <a:off x="4937760" y="4411980"/>
-            <a:ext cx="6675119" cy="384048"/>
+            <a:off x="4651247" y="4690872"/>
+            <a:ext cx="2895599" cy="365760"/>
           </a:xfrm>
           <a:prstGeom prst="rect">
             <a:avLst/>
@@ -5128,74 +4513,116 @@
               </a:spcAft>
             </a:pPr>
             <a:r>
-              <a:rPr sz="1400" b="1">
-                <a:solidFill>
-                  <a:srgbClr val="1A1A1A"/>
+              <a:rPr sz="1250" b="1">
+                <a:solidFill>
+                  <a:srgbClr val="1428A0"/>
                 </a:solidFill>
                 <a:latin typeface="Pretendard"/>
                 <a:ea typeface="Pretendard"/>
               </a:rPr>
-              <a:t>세트(DX) 원가 부담</a:t>
-            </a:r>
-          </a:p>
-        </p:txBody>
-      </p:sp>
-      <p:sp>
-        <p:nvSpPr>
-          <p:cNvPr id="16" name="TextBox 15"/>
+              <a:t>메모리·HBM 견인</a:t>
+            </a:r>
+          </a:p>
+        </p:txBody>
+      </p:sp>
+      <p:sp>
+        <p:nvSpPr>
+          <p:cNvPr id="17" name="Rectangle 16"/>
+          <p:cNvSpPr/>
+          <p:nvPr/>
+        </p:nvSpPr>
+        <p:spPr>
+          <a:xfrm>
+            <a:off x="8186927" y="2788920"/>
+            <a:ext cx="3444239" cy="2468880"/>
+          </a:xfrm>
+          <a:prstGeom prst="rect">
+            <a:avLst/>
+          </a:prstGeom>
+          <a:solidFill>
+            <a:srgbClr val="F5F6F8"/>
+          </a:solidFill>
+          <a:ln>
+            <a:noFill/>
+          </a:ln>
+          <a:effectLst/>
+        </p:spPr>
+        <p:style>
+          <a:lnRef idx="1">
+            <a:schemeClr val="accent1"/>
+          </a:lnRef>
+          <a:fillRef idx="3">
+            <a:schemeClr val="accent1"/>
+          </a:fillRef>
+          <a:effectRef idx="2">
+            <a:schemeClr val="accent1"/>
+          </a:effectRef>
+          <a:fontRef idx="minor">
+            <a:schemeClr val="lt1"/>
+          </a:fontRef>
+        </p:style>
+        <p:txBody>
+          <a:bodyPr rtlCol="0" anchor="ctr"/>
+          <a:lstStyle/>
+          <a:p>
+            <a:pPr algn="ctr"/>
+          </a:p>
+        </p:txBody>
+      </p:sp>
+      <p:sp>
+        <p:nvSpPr>
+          <p:cNvPr id="18" name="Rectangle 17"/>
+          <p:cNvSpPr/>
+          <p:nvPr/>
+        </p:nvSpPr>
+        <p:spPr>
+          <a:xfrm>
+            <a:off x="8186927" y="2788920"/>
+            <a:ext cx="3444239" cy="73152"/>
+          </a:xfrm>
+          <a:prstGeom prst="rect">
+            <a:avLst/>
+          </a:prstGeom>
+          <a:solidFill>
+            <a:srgbClr val="1428A0"/>
+          </a:solidFill>
+          <a:ln>
+            <a:noFill/>
+          </a:ln>
+          <a:effectLst/>
+        </p:spPr>
+        <p:style>
+          <a:lnRef idx="1">
+            <a:schemeClr val="accent1"/>
+          </a:lnRef>
+          <a:fillRef idx="3">
+            <a:schemeClr val="accent1"/>
+          </a:fillRef>
+          <a:effectRef idx="2">
+            <a:schemeClr val="accent1"/>
+          </a:effectRef>
+          <a:fontRef idx="minor">
+            <a:schemeClr val="lt1"/>
+          </a:fontRef>
+        </p:style>
+        <p:txBody>
+          <a:bodyPr rtlCol="0" anchor="ctr"/>
+          <a:lstStyle/>
+          <a:p>
+            <a:pPr algn="ctr"/>
+          </a:p>
+        </p:txBody>
+      </p:sp>
+      <p:sp>
+        <p:nvSpPr>
+          <p:cNvPr id="19" name="TextBox 18"/>
           <p:cNvSpPr txBox="1"/>
           <p:nvPr/>
         </p:nvSpPr>
         <p:spPr>
           <a:xfrm>
-            <a:off x="4937760" y="4796028"/>
-            <a:ext cx="6675119" cy="422910"/>
-          </a:xfrm>
-          <a:prstGeom prst="rect">
-            <a:avLst/>
-          </a:prstGeom>
-          <a:noFill/>
-        </p:spPr>
-        <p:txBody>
-          <a:bodyPr wrap="square" anchor="t" lIns="0" rIns="0" tIns="0" bIns="0">
-            <a:spAutoFit/>
-          </a:bodyPr>
-          <a:lstStyle/>
-          <a:p>
-            <a:pPr algn="l">
-              <a:lnSpc>
-                <a:spcPct val="132000"/>
-              </a:lnSpc>
-              <a:spcBef>
-                <a:spcPts val="0"/>
-              </a:spcBef>
-              <a:spcAft>
-                <a:spcPts val="0"/>
-              </a:spcAft>
-            </a:pPr>
-            <a:r>
-              <a:rPr sz="1150" b="0">
-                <a:solidFill>
-                  <a:srgbClr val="4A4A4A"/>
-                </a:solidFill>
-                <a:latin typeface="Pretendard"/>
-                <a:ea typeface="Pretendard"/>
-              </a:rPr>
-              <a:t>스마트폰·가전은 메모리 원가 상승분 전가 지연으로 수익성 둔화.</a:t>
-            </a:r>
-          </a:p>
-        </p:txBody>
-      </p:sp>
-      <p:sp>
-        <p:nvSpPr>
-          <p:cNvPr id="17" name="TextBox 16"/>
-          <p:cNvSpPr txBox="1"/>
-          <p:nvPr/>
-        </p:nvSpPr>
-        <p:spPr>
-          <a:xfrm>
-            <a:off x="4023360" y="5292090"/>
-            <a:ext cx="868680" cy="548640"/>
+            <a:off x="8461247" y="3154679"/>
+            <a:ext cx="2895599" cy="365760"/>
           </a:xfrm>
           <a:prstGeom prst="rect">
             <a:avLst/>
@@ -5220,28 +4647,28 @@
               </a:spcAft>
             </a:pPr>
             <a:r>
-              <a:rPr sz="2100" b="1">
-                <a:solidFill>
-                  <a:srgbClr val="1428A0"/>
+              <a:rPr sz="1200" b="0">
+                <a:solidFill>
+                  <a:srgbClr val="4A4A4A"/>
                 </a:solidFill>
                 <a:latin typeface="Pretendard"/>
                 <a:ea typeface="Pretendard"/>
               </a:rPr>
-              <a:t>04</a:t>
-            </a:r>
-          </a:p>
-        </p:txBody>
-      </p:sp>
-      <p:sp>
-        <p:nvSpPr>
-          <p:cNvPr id="18" name="TextBox 17"/>
+              <a:t>DX 영업이익 (Q1'26)</a:t>
+            </a:r>
+          </a:p>
+        </p:txBody>
+      </p:sp>
+      <p:sp>
+        <p:nvSpPr>
+          <p:cNvPr id="20" name="TextBox 19"/>
           <p:cNvSpPr txBox="1"/>
           <p:nvPr/>
         </p:nvSpPr>
         <p:spPr>
           <a:xfrm>
-            <a:off x="4937760" y="5292090"/>
-            <a:ext cx="6675119" cy="384048"/>
+            <a:off x="8461247" y="3630168"/>
+            <a:ext cx="2895599" cy="914400"/>
           </a:xfrm>
           <a:prstGeom prst="rect">
             <a:avLst/>
@@ -5266,28 +4693,28 @@
               </a:spcAft>
             </a:pPr>
             <a:r>
-              <a:rPr sz="1400" b="1">
+              <a:rPr sz="3300" b="1">
                 <a:solidFill>
                   <a:srgbClr val="1A1A1A"/>
                 </a:solidFill>
                 <a:latin typeface="Pretendard"/>
                 <a:ea typeface="Pretendard"/>
               </a:rPr>
-              <a:t>연간 전망</a:t>
-            </a:r>
-          </a:p>
-        </p:txBody>
-      </p:sp>
-      <p:sp>
-        <p:nvSpPr>
-          <p:cNvPr id="19" name="TextBox 18"/>
+              <a:t>3.0조원</a:t>
+            </a:r>
+          </a:p>
+        </p:txBody>
+      </p:sp>
+      <p:sp>
+        <p:nvSpPr>
+          <p:cNvPr id="21" name="TextBox 20"/>
           <p:cNvSpPr txBox="1"/>
           <p:nvPr/>
         </p:nvSpPr>
         <p:spPr>
           <a:xfrm>
-            <a:off x="4937760" y="5676138"/>
-            <a:ext cx="6675119" cy="422910"/>
+            <a:off x="8461247" y="4690872"/>
+            <a:ext cx="2895599" cy="365760"/>
           </a:xfrm>
           <a:prstGeom prst="rect">
             <a:avLst/>
@@ -5302,7 +4729,7 @@
           <a:p>
             <a:pPr algn="l">
               <a:lnSpc>
-                <a:spcPct val="132000"/>
+                <a:spcPct val="115000"/>
               </a:lnSpc>
               <a:spcBef>
                 <a:spcPts val="0"/>
@@ -5312,14 +4739,14 @@
               </a:spcAft>
             </a:pPr>
             <a:r>
-              <a:rPr sz="1150" b="0">
-                <a:solidFill>
-                  <a:srgbClr val="4A4A4A"/>
+              <a:rPr sz="1250" b="1">
+                <a:solidFill>
+                  <a:srgbClr val="1428A0"/>
                 </a:solidFill>
                 <a:latin typeface="Pretendard"/>
                 <a:ea typeface="Pretendard"/>
               </a:rPr>
-              <a:t>시장은 AI·HBM·파운드리 개선으로 2026년 강한 이익 흐름을 전망(추정).</a:t>
+              <a:t>메모리 원가 부담</a:t>
             </a:r>
           </a:p>
         </p:txBody>
@@ -5333,6 +4760,856 @@
 </file>
 
 <file path=ppt/slides/slide13.xml><?xml version="1.0" encoding="utf-8"?>
+<p:sld xmlns:a="http://schemas.openxmlformats.org/drawingml/2006/main" xmlns:p="http://schemas.openxmlformats.org/presentationml/2006/main" xmlns:r="http://schemas.openxmlformats.org/officeDocument/2006/relationships">
+  <p:cSld>
+    <p:bg>
+      <p:bgPr>
+        <a:solidFill>
+          <a:srgbClr val="FFFFFF"/>
+        </a:solidFill>
+        <a:effectLst/>
+      </p:bgPr>
+    </p:bg>
+    <p:spTree>
+      <p:nvGrpSpPr>
+        <p:cNvPr id="1" name=""/>
+        <p:cNvGrpSpPr/>
+        <p:nvPr/>
+      </p:nvGrpSpPr>
+      <p:grpSpPr/>
+      <p:sp>
+        <p:nvSpPr>
+          <p:cNvPr id="2" name="TextBox 1"/>
+          <p:cNvSpPr txBox="1"/>
+          <p:nvPr/>
+        </p:nvSpPr>
+        <p:spPr>
+          <a:xfrm>
+            <a:off x="566928" y="402336"/>
+            <a:ext cx="8686800" cy="292608"/>
+          </a:xfrm>
+          <a:prstGeom prst="rect">
+            <a:avLst/>
+          </a:prstGeom>
+          <a:noFill/>
+        </p:spPr>
+        <p:txBody>
+          <a:bodyPr wrap="square" anchor="t" lIns="0" rIns="0" tIns="0" bIns="0">
+            <a:spAutoFit/>
+          </a:bodyPr>
+          <a:lstStyle/>
+          <a:p>
+            <a:pPr algn="l">
+              <a:lnSpc>
+                <a:spcPct val="115000"/>
+              </a:lnSpc>
+              <a:spcBef>
+                <a:spcPts val="0"/>
+              </a:spcBef>
+              <a:spcAft>
+                <a:spcPts val="0"/>
+              </a:spcAft>
+            </a:pPr>
+            <a:r>
+              <a:rPr sz="1100" b="1" spc="120">
+                <a:solidFill>
+                  <a:srgbClr val="1428A0"/>
+                </a:solidFill>
+                <a:latin typeface="Pretendard"/>
+                <a:ea typeface="Pretendard"/>
+              </a:rPr>
+              <a:t>05 · 사업 현황 · 전망</a:t>
+            </a:r>
+          </a:p>
+        </p:txBody>
+      </p:sp>
+      <p:sp>
+        <p:nvSpPr>
+          <p:cNvPr id="3" name="TextBox 2"/>
+          <p:cNvSpPr txBox="1"/>
+          <p:nvPr/>
+        </p:nvSpPr>
+        <p:spPr>
+          <a:xfrm>
+            <a:off x="566928" y="841248"/>
+            <a:ext cx="11064240" cy="914400"/>
+          </a:xfrm>
+          <a:prstGeom prst="rect">
+            <a:avLst/>
+          </a:prstGeom>
+          <a:noFill/>
+        </p:spPr>
+        <p:txBody>
+          <a:bodyPr wrap="square" anchor="t" lIns="0" rIns="0" tIns="0" bIns="0">
+            <a:spAutoFit/>
+          </a:bodyPr>
+          <a:lstStyle/>
+          <a:p>
+            <a:pPr algn="l">
+              <a:lnSpc>
+                <a:spcPct val="115000"/>
+              </a:lnSpc>
+              <a:spcBef>
+                <a:spcPts val="0"/>
+              </a:spcBef>
+              <a:spcAft>
+                <a:spcPts val="0"/>
+              </a:spcAft>
+            </a:pPr>
+            <a:r>
+              <a:rPr sz="2500" b="1">
+                <a:solidFill>
+                  <a:srgbClr val="1A1A1A"/>
+                </a:solidFill>
+                <a:latin typeface="Pretendard"/>
+                <a:ea typeface="Pretendard"/>
+              </a:rPr>
+              <a:t>핵심 하이라이트 · 전망</a:t>
+            </a:r>
+          </a:p>
+        </p:txBody>
+      </p:sp>
+      <p:sp>
+        <p:nvSpPr>
+          <p:cNvPr id="4" name="TextBox 3"/>
+          <p:cNvSpPr txBox="1"/>
+          <p:nvPr/>
+        </p:nvSpPr>
+        <p:spPr>
+          <a:xfrm>
+            <a:off x="566928" y="1627632"/>
+            <a:ext cx="11064240" cy="548640"/>
+          </a:xfrm>
+          <a:prstGeom prst="rect">
+            <a:avLst/>
+          </a:prstGeom>
+          <a:noFill/>
+        </p:spPr>
+        <p:txBody>
+          <a:bodyPr wrap="square" anchor="t" lIns="0" rIns="0" tIns="0" bIns="0">
+            <a:spAutoFit/>
+          </a:bodyPr>
+          <a:lstStyle/>
+          <a:p>
+            <a:pPr algn="l">
+              <a:lnSpc>
+                <a:spcPct val="115000"/>
+              </a:lnSpc>
+              <a:spcBef>
+                <a:spcPts val="0"/>
+              </a:spcBef>
+              <a:spcAft>
+                <a:spcPts val="0"/>
+              </a:spcAft>
+            </a:pPr>
+            <a:r>
+              <a:rPr sz="1400" b="0">
+                <a:solidFill>
+                  <a:srgbClr val="4A4A4A"/>
+                </a:solidFill>
+                <a:latin typeface="Pretendard"/>
+                <a:ea typeface="Pretendard"/>
+              </a:rPr>
+              <a:t>AI 서버 수요가 메모리 실적 급증을 견인</a:t>
+            </a:r>
+          </a:p>
+        </p:txBody>
+      </p:sp>
+      <p:sp>
+        <p:nvSpPr>
+          <p:cNvPr id="5" name="Rectangle 4"/>
+          <p:cNvSpPr/>
+          <p:nvPr/>
+        </p:nvSpPr>
+        <p:spPr>
+          <a:xfrm>
+            <a:off x="566928" y="2194560"/>
+            <a:ext cx="1005840" cy="41148"/>
+          </a:xfrm>
+          <a:prstGeom prst="rect">
+            <a:avLst/>
+          </a:prstGeom>
+          <a:solidFill>
+            <a:srgbClr val="1428A0"/>
+          </a:solidFill>
+          <a:ln>
+            <a:noFill/>
+          </a:ln>
+          <a:effectLst/>
+        </p:spPr>
+        <p:style>
+          <a:lnRef idx="1">
+            <a:schemeClr val="accent1"/>
+          </a:lnRef>
+          <a:fillRef idx="3">
+            <a:schemeClr val="accent1"/>
+          </a:fillRef>
+          <a:effectRef idx="2">
+            <a:schemeClr val="accent1"/>
+          </a:effectRef>
+          <a:fontRef idx="minor">
+            <a:schemeClr val="lt1"/>
+          </a:fontRef>
+        </p:style>
+        <p:txBody>
+          <a:bodyPr rtlCol="0" anchor="ctr"/>
+          <a:lstStyle/>
+          <a:p>
+            <a:pPr algn="ctr"/>
+          </a:p>
+        </p:txBody>
+      </p:sp>
+      <p:sp>
+        <p:nvSpPr>
+          <p:cNvPr id="6" name="Rectangle 5"/>
+          <p:cNvSpPr/>
+          <p:nvPr/>
+        </p:nvSpPr>
+        <p:spPr>
+          <a:xfrm>
+            <a:off x="1572768" y="2211019"/>
+            <a:ext cx="10058400" cy="10972"/>
+          </a:xfrm>
+          <a:prstGeom prst="rect">
+            <a:avLst/>
+          </a:prstGeom>
+          <a:solidFill>
+            <a:srgbClr val="E1E3E8"/>
+          </a:solidFill>
+          <a:ln>
+            <a:noFill/>
+          </a:ln>
+          <a:effectLst/>
+        </p:spPr>
+        <p:style>
+          <a:lnRef idx="1">
+            <a:schemeClr val="accent1"/>
+          </a:lnRef>
+          <a:fillRef idx="3">
+            <a:schemeClr val="accent1"/>
+          </a:fillRef>
+          <a:effectRef idx="2">
+            <a:schemeClr val="accent1"/>
+          </a:effectRef>
+          <a:fontRef idx="minor">
+            <a:schemeClr val="lt1"/>
+          </a:fontRef>
+        </p:style>
+        <p:txBody>
+          <a:bodyPr rtlCol="0" anchor="ctr"/>
+          <a:lstStyle/>
+          <a:p>
+            <a:pPr algn="ctr"/>
+          </a:p>
+        </p:txBody>
+      </p:sp>
+      <p:sp>
+        <p:nvSpPr>
+          <p:cNvPr id="7" name="TextBox 6"/>
+          <p:cNvSpPr txBox="1"/>
+          <p:nvPr/>
+        </p:nvSpPr>
+        <p:spPr>
+          <a:xfrm>
+            <a:off x="566928" y="2697480"/>
+            <a:ext cx="3017520" cy="3291840"/>
+          </a:xfrm>
+          <a:prstGeom prst="rect">
+            <a:avLst/>
+          </a:prstGeom>
+          <a:noFill/>
+        </p:spPr>
+        <p:txBody>
+          <a:bodyPr wrap="square" anchor="t" lIns="0" rIns="0" tIns="0" bIns="0">
+            <a:spAutoFit/>
+          </a:bodyPr>
+          <a:lstStyle/>
+          <a:p>
+            <a:pPr algn="l">
+              <a:lnSpc>
+                <a:spcPct val="150000"/>
+              </a:lnSpc>
+              <a:spcBef>
+                <a:spcPts val="0"/>
+              </a:spcBef>
+              <a:spcAft>
+                <a:spcPts val="0"/>
+              </a:spcAft>
+            </a:pPr>
+            <a:r>
+              <a:rPr sz="1250" b="0">
+                <a:solidFill>
+                  <a:srgbClr val="4A4A4A"/>
+                </a:solidFill>
+                <a:latin typeface="Pretendard"/>
+                <a:ea typeface="Pretendard"/>
+              </a:rPr>
+              <a:t>HBM·서버 D램·SSD 수요 확대와 메모리 가격 상승이 실적을 이끌었습니다.</a:t>
+            </a:r>
+          </a:p>
+        </p:txBody>
+      </p:sp>
+      <p:sp>
+        <p:nvSpPr>
+          <p:cNvPr id="8" name="TextBox 7"/>
+          <p:cNvSpPr txBox="1"/>
+          <p:nvPr/>
+        </p:nvSpPr>
+        <p:spPr>
+          <a:xfrm>
+            <a:off x="4023360" y="2651760"/>
+            <a:ext cx="868680" cy="548640"/>
+          </a:xfrm>
+          <a:prstGeom prst="rect">
+            <a:avLst/>
+          </a:prstGeom>
+          <a:noFill/>
+        </p:spPr>
+        <p:txBody>
+          <a:bodyPr wrap="square" anchor="t" lIns="0" rIns="0" tIns="0" bIns="0">
+            <a:spAutoFit/>
+          </a:bodyPr>
+          <a:lstStyle/>
+          <a:p>
+            <a:pPr algn="l">
+              <a:lnSpc>
+                <a:spcPct val="115000"/>
+              </a:lnSpc>
+              <a:spcBef>
+                <a:spcPts val="0"/>
+              </a:spcBef>
+              <a:spcAft>
+                <a:spcPts val="0"/>
+              </a:spcAft>
+            </a:pPr>
+            <a:r>
+              <a:rPr sz="2100" b="1">
+                <a:solidFill>
+                  <a:srgbClr val="1428A0"/>
+                </a:solidFill>
+                <a:latin typeface="Pretendard"/>
+                <a:ea typeface="Pretendard"/>
+              </a:rPr>
+              <a:t>01</a:t>
+            </a:r>
+          </a:p>
+        </p:txBody>
+      </p:sp>
+      <p:sp>
+        <p:nvSpPr>
+          <p:cNvPr id="9" name="TextBox 8"/>
+          <p:cNvSpPr txBox="1"/>
+          <p:nvPr/>
+        </p:nvSpPr>
+        <p:spPr>
+          <a:xfrm>
+            <a:off x="4937760" y="2651760"/>
+            <a:ext cx="6675119" cy="384048"/>
+          </a:xfrm>
+          <a:prstGeom prst="rect">
+            <a:avLst/>
+          </a:prstGeom>
+          <a:noFill/>
+        </p:spPr>
+        <p:txBody>
+          <a:bodyPr wrap="square" anchor="t" lIns="0" rIns="0" tIns="0" bIns="0">
+            <a:spAutoFit/>
+          </a:bodyPr>
+          <a:lstStyle/>
+          <a:p>
+            <a:pPr algn="l">
+              <a:lnSpc>
+                <a:spcPct val="115000"/>
+              </a:lnSpc>
+              <a:spcBef>
+                <a:spcPts val="0"/>
+              </a:spcBef>
+              <a:spcAft>
+                <a:spcPts val="0"/>
+              </a:spcAft>
+            </a:pPr>
+            <a:r>
+              <a:rPr sz="1400" b="1">
+                <a:solidFill>
+                  <a:srgbClr val="1A1A1A"/>
+                </a:solidFill>
+                <a:latin typeface="Pretendard"/>
+                <a:ea typeface="Pretendard"/>
+              </a:rPr>
+              <a:t>메모리 슈퍼사이클</a:t>
+            </a:r>
+          </a:p>
+        </p:txBody>
+      </p:sp>
+      <p:sp>
+        <p:nvSpPr>
+          <p:cNvPr id="10" name="TextBox 9"/>
+          <p:cNvSpPr txBox="1"/>
+          <p:nvPr/>
+        </p:nvSpPr>
+        <p:spPr>
+          <a:xfrm>
+            <a:off x="4937760" y="3035808"/>
+            <a:ext cx="6675119" cy="422910"/>
+          </a:xfrm>
+          <a:prstGeom prst="rect">
+            <a:avLst/>
+          </a:prstGeom>
+          <a:noFill/>
+        </p:spPr>
+        <p:txBody>
+          <a:bodyPr wrap="square" anchor="t" lIns="0" rIns="0" tIns="0" bIns="0">
+            <a:spAutoFit/>
+          </a:bodyPr>
+          <a:lstStyle/>
+          <a:p>
+            <a:pPr algn="l">
+              <a:lnSpc>
+                <a:spcPct val="132000"/>
+              </a:lnSpc>
+              <a:spcBef>
+                <a:spcPts val="0"/>
+              </a:spcBef>
+              <a:spcAft>
+                <a:spcPts val="0"/>
+              </a:spcAft>
+            </a:pPr>
+            <a:r>
+              <a:rPr sz="1150" b="0">
+                <a:solidFill>
+                  <a:srgbClr val="4A4A4A"/>
+                </a:solidFill>
+                <a:latin typeface="Pretendard"/>
+                <a:ea typeface="Pretendard"/>
+              </a:rPr>
+              <a:t>AI 서버향 HBM·D램·SSD 수요와 가격 상승이 실적 급증의 핵심 동인.</a:t>
+            </a:r>
+          </a:p>
+        </p:txBody>
+      </p:sp>
+      <p:sp>
+        <p:nvSpPr>
+          <p:cNvPr id="11" name="TextBox 10"/>
+          <p:cNvSpPr txBox="1"/>
+          <p:nvPr/>
+        </p:nvSpPr>
+        <p:spPr>
+          <a:xfrm>
+            <a:off x="4023360" y="3531870"/>
+            <a:ext cx="868680" cy="548640"/>
+          </a:xfrm>
+          <a:prstGeom prst="rect">
+            <a:avLst/>
+          </a:prstGeom>
+          <a:noFill/>
+        </p:spPr>
+        <p:txBody>
+          <a:bodyPr wrap="square" anchor="t" lIns="0" rIns="0" tIns="0" bIns="0">
+            <a:spAutoFit/>
+          </a:bodyPr>
+          <a:lstStyle/>
+          <a:p>
+            <a:pPr algn="l">
+              <a:lnSpc>
+                <a:spcPct val="115000"/>
+              </a:lnSpc>
+              <a:spcBef>
+                <a:spcPts val="0"/>
+              </a:spcBef>
+              <a:spcAft>
+                <a:spcPts val="0"/>
+              </a:spcAft>
+            </a:pPr>
+            <a:r>
+              <a:rPr sz="2100" b="1">
+                <a:solidFill>
+                  <a:srgbClr val="1428A0"/>
+                </a:solidFill>
+                <a:latin typeface="Pretendard"/>
+                <a:ea typeface="Pretendard"/>
+              </a:rPr>
+              <a:t>02</a:t>
+            </a:r>
+          </a:p>
+        </p:txBody>
+      </p:sp>
+      <p:sp>
+        <p:nvSpPr>
+          <p:cNvPr id="12" name="TextBox 11"/>
+          <p:cNvSpPr txBox="1"/>
+          <p:nvPr/>
+        </p:nvSpPr>
+        <p:spPr>
+          <a:xfrm>
+            <a:off x="4937760" y="3531870"/>
+            <a:ext cx="6675119" cy="384048"/>
+          </a:xfrm>
+          <a:prstGeom prst="rect">
+            <a:avLst/>
+          </a:prstGeom>
+          <a:noFill/>
+        </p:spPr>
+        <p:txBody>
+          <a:bodyPr wrap="square" anchor="t" lIns="0" rIns="0" tIns="0" bIns="0">
+            <a:spAutoFit/>
+          </a:bodyPr>
+          <a:lstStyle/>
+          <a:p>
+            <a:pPr algn="l">
+              <a:lnSpc>
+                <a:spcPct val="115000"/>
+              </a:lnSpc>
+              <a:spcBef>
+                <a:spcPts val="0"/>
+              </a:spcBef>
+              <a:spcAft>
+                <a:spcPts val="0"/>
+              </a:spcAft>
+            </a:pPr>
+            <a:r>
+              <a:rPr sz="1400" b="1">
+                <a:solidFill>
+                  <a:srgbClr val="1A1A1A"/>
+                </a:solidFill>
+                <a:latin typeface="Pretendard"/>
+                <a:ea typeface="Pretendard"/>
+              </a:rPr>
+              <a:t>반도체(DS) 견인</a:t>
+            </a:r>
+          </a:p>
+        </p:txBody>
+      </p:sp>
+      <p:sp>
+        <p:nvSpPr>
+          <p:cNvPr id="13" name="TextBox 12"/>
+          <p:cNvSpPr txBox="1"/>
+          <p:nvPr/>
+        </p:nvSpPr>
+        <p:spPr>
+          <a:xfrm>
+            <a:off x="4937760" y="3915918"/>
+            <a:ext cx="6675119" cy="422910"/>
+          </a:xfrm>
+          <a:prstGeom prst="rect">
+            <a:avLst/>
+          </a:prstGeom>
+          <a:noFill/>
+        </p:spPr>
+        <p:txBody>
+          <a:bodyPr wrap="square" anchor="t" lIns="0" rIns="0" tIns="0" bIns="0">
+            <a:spAutoFit/>
+          </a:bodyPr>
+          <a:lstStyle/>
+          <a:p>
+            <a:pPr algn="l">
+              <a:lnSpc>
+                <a:spcPct val="132000"/>
+              </a:lnSpc>
+              <a:spcBef>
+                <a:spcPts val="0"/>
+              </a:spcBef>
+              <a:spcAft>
+                <a:spcPts val="0"/>
+              </a:spcAft>
+            </a:pPr>
+            <a:r>
+              <a:rPr sz="1150" b="0">
+                <a:solidFill>
+                  <a:srgbClr val="4A4A4A"/>
+                </a:solidFill>
+                <a:latin typeface="Pretendard"/>
+                <a:ea typeface="Pretendard"/>
+              </a:rPr>
+              <a:t>DS 부문이 전사 영업이익의 대부분을 차지, 이익 쏠림이 심화.</a:t>
+            </a:r>
+          </a:p>
+        </p:txBody>
+      </p:sp>
+      <p:sp>
+        <p:nvSpPr>
+          <p:cNvPr id="14" name="TextBox 13"/>
+          <p:cNvSpPr txBox="1"/>
+          <p:nvPr/>
+        </p:nvSpPr>
+        <p:spPr>
+          <a:xfrm>
+            <a:off x="4023360" y="4411980"/>
+            <a:ext cx="868680" cy="548640"/>
+          </a:xfrm>
+          <a:prstGeom prst="rect">
+            <a:avLst/>
+          </a:prstGeom>
+          <a:noFill/>
+        </p:spPr>
+        <p:txBody>
+          <a:bodyPr wrap="square" anchor="t" lIns="0" rIns="0" tIns="0" bIns="0">
+            <a:spAutoFit/>
+          </a:bodyPr>
+          <a:lstStyle/>
+          <a:p>
+            <a:pPr algn="l">
+              <a:lnSpc>
+                <a:spcPct val="115000"/>
+              </a:lnSpc>
+              <a:spcBef>
+                <a:spcPts val="0"/>
+              </a:spcBef>
+              <a:spcAft>
+                <a:spcPts val="0"/>
+              </a:spcAft>
+            </a:pPr>
+            <a:r>
+              <a:rPr sz="2100" b="1">
+                <a:solidFill>
+                  <a:srgbClr val="1428A0"/>
+                </a:solidFill>
+                <a:latin typeface="Pretendard"/>
+                <a:ea typeface="Pretendard"/>
+              </a:rPr>
+              <a:t>03</a:t>
+            </a:r>
+          </a:p>
+        </p:txBody>
+      </p:sp>
+      <p:sp>
+        <p:nvSpPr>
+          <p:cNvPr id="15" name="TextBox 14"/>
+          <p:cNvSpPr txBox="1"/>
+          <p:nvPr/>
+        </p:nvSpPr>
+        <p:spPr>
+          <a:xfrm>
+            <a:off x="4937760" y="4411980"/>
+            <a:ext cx="6675119" cy="384048"/>
+          </a:xfrm>
+          <a:prstGeom prst="rect">
+            <a:avLst/>
+          </a:prstGeom>
+          <a:noFill/>
+        </p:spPr>
+        <p:txBody>
+          <a:bodyPr wrap="square" anchor="t" lIns="0" rIns="0" tIns="0" bIns="0">
+            <a:spAutoFit/>
+          </a:bodyPr>
+          <a:lstStyle/>
+          <a:p>
+            <a:pPr algn="l">
+              <a:lnSpc>
+                <a:spcPct val="115000"/>
+              </a:lnSpc>
+              <a:spcBef>
+                <a:spcPts val="0"/>
+              </a:spcBef>
+              <a:spcAft>
+                <a:spcPts val="0"/>
+              </a:spcAft>
+            </a:pPr>
+            <a:r>
+              <a:rPr sz="1400" b="1">
+                <a:solidFill>
+                  <a:srgbClr val="1A1A1A"/>
+                </a:solidFill>
+                <a:latin typeface="Pretendard"/>
+                <a:ea typeface="Pretendard"/>
+              </a:rPr>
+              <a:t>세트(DX) 원가 부담</a:t>
+            </a:r>
+          </a:p>
+        </p:txBody>
+      </p:sp>
+      <p:sp>
+        <p:nvSpPr>
+          <p:cNvPr id="16" name="TextBox 15"/>
+          <p:cNvSpPr txBox="1"/>
+          <p:nvPr/>
+        </p:nvSpPr>
+        <p:spPr>
+          <a:xfrm>
+            <a:off x="4937760" y="4796028"/>
+            <a:ext cx="6675119" cy="422910"/>
+          </a:xfrm>
+          <a:prstGeom prst="rect">
+            <a:avLst/>
+          </a:prstGeom>
+          <a:noFill/>
+        </p:spPr>
+        <p:txBody>
+          <a:bodyPr wrap="square" anchor="t" lIns="0" rIns="0" tIns="0" bIns="0">
+            <a:spAutoFit/>
+          </a:bodyPr>
+          <a:lstStyle/>
+          <a:p>
+            <a:pPr algn="l">
+              <a:lnSpc>
+                <a:spcPct val="132000"/>
+              </a:lnSpc>
+              <a:spcBef>
+                <a:spcPts val="0"/>
+              </a:spcBef>
+              <a:spcAft>
+                <a:spcPts val="0"/>
+              </a:spcAft>
+            </a:pPr>
+            <a:r>
+              <a:rPr sz="1150" b="0">
+                <a:solidFill>
+                  <a:srgbClr val="4A4A4A"/>
+                </a:solidFill>
+                <a:latin typeface="Pretendard"/>
+                <a:ea typeface="Pretendard"/>
+              </a:rPr>
+              <a:t>스마트폰·가전은 메모리 원가 상승분 전가 지연으로 수익성 둔화.</a:t>
+            </a:r>
+          </a:p>
+        </p:txBody>
+      </p:sp>
+      <p:sp>
+        <p:nvSpPr>
+          <p:cNvPr id="17" name="TextBox 16"/>
+          <p:cNvSpPr txBox="1"/>
+          <p:nvPr/>
+        </p:nvSpPr>
+        <p:spPr>
+          <a:xfrm>
+            <a:off x="4023360" y="5292090"/>
+            <a:ext cx="868680" cy="548640"/>
+          </a:xfrm>
+          <a:prstGeom prst="rect">
+            <a:avLst/>
+          </a:prstGeom>
+          <a:noFill/>
+        </p:spPr>
+        <p:txBody>
+          <a:bodyPr wrap="square" anchor="t" lIns="0" rIns="0" tIns="0" bIns="0">
+            <a:spAutoFit/>
+          </a:bodyPr>
+          <a:lstStyle/>
+          <a:p>
+            <a:pPr algn="l">
+              <a:lnSpc>
+                <a:spcPct val="115000"/>
+              </a:lnSpc>
+              <a:spcBef>
+                <a:spcPts val="0"/>
+              </a:spcBef>
+              <a:spcAft>
+                <a:spcPts val="0"/>
+              </a:spcAft>
+            </a:pPr>
+            <a:r>
+              <a:rPr sz="2100" b="1">
+                <a:solidFill>
+                  <a:srgbClr val="1428A0"/>
+                </a:solidFill>
+                <a:latin typeface="Pretendard"/>
+                <a:ea typeface="Pretendard"/>
+              </a:rPr>
+              <a:t>04</a:t>
+            </a:r>
+          </a:p>
+        </p:txBody>
+      </p:sp>
+      <p:sp>
+        <p:nvSpPr>
+          <p:cNvPr id="18" name="TextBox 17"/>
+          <p:cNvSpPr txBox="1"/>
+          <p:nvPr/>
+        </p:nvSpPr>
+        <p:spPr>
+          <a:xfrm>
+            <a:off x="4937760" y="5292090"/>
+            <a:ext cx="6675119" cy="384048"/>
+          </a:xfrm>
+          <a:prstGeom prst="rect">
+            <a:avLst/>
+          </a:prstGeom>
+          <a:noFill/>
+        </p:spPr>
+        <p:txBody>
+          <a:bodyPr wrap="square" anchor="t" lIns="0" rIns="0" tIns="0" bIns="0">
+            <a:spAutoFit/>
+          </a:bodyPr>
+          <a:lstStyle/>
+          <a:p>
+            <a:pPr algn="l">
+              <a:lnSpc>
+                <a:spcPct val="115000"/>
+              </a:lnSpc>
+              <a:spcBef>
+                <a:spcPts val="0"/>
+              </a:spcBef>
+              <a:spcAft>
+                <a:spcPts val="0"/>
+              </a:spcAft>
+            </a:pPr>
+            <a:r>
+              <a:rPr sz="1400" b="1">
+                <a:solidFill>
+                  <a:srgbClr val="1A1A1A"/>
+                </a:solidFill>
+                <a:latin typeface="Pretendard"/>
+                <a:ea typeface="Pretendard"/>
+              </a:rPr>
+              <a:t>연간 전망</a:t>
+            </a:r>
+          </a:p>
+        </p:txBody>
+      </p:sp>
+      <p:sp>
+        <p:nvSpPr>
+          <p:cNvPr id="19" name="TextBox 18"/>
+          <p:cNvSpPr txBox="1"/>
+          <p:nvPr/>
+        </p:nvSpPr>
+        <p:spPr>
+          <a:xfrm>
+            <a:off x="4937760" y="5676138"/>
+            <a:ext cx="6675119" cy="422910"/>
+          </a:xfrm>
+          <a:prstGeom prst="rect">
+            <a:avLst/>
+          </a:prstGeom>
+          <a:noFill/>
+        </p:spPr>
+        <p:txBody>
+          <a:bodyPr wrap="square" anchor="t" lIns="0" rIns="0" tIns="0" bIns="0">
+            <a:spAutoFit/>
+          </a:bodyPr>
+          <a:lstStyle/>
+          <a:p>
+            <a:pPr algn="l">
+              <a:lnSpc>
+                <a:spcPct val="132000"/>
+              </a:lnSpc>
+              <a:spcBef>
+                <a:spcPts val="0"/>
+              </a:spcBef>
+              <a:spcAft>
+                <a:spcPts val="0"/>
+              </a:spcAft>
+            </a:pPr>
+            <a:r>
+              <a:rPr sz="1150" b="0">
+                <a:solidFill>
+                  <a:srgbClr val="4A4A4A"/>
+                </a:solidFill>
+                <a:latin typeface="Pretendard"/>
+                <a:ea typeface="Pretendard"/>
+              </a:rPr>
+              <a:t>시장은 AI·HBM·파운드리 개선으로 2026년 강한 이익 흐름을 전망(추정).</a:t>
+            </a:r>
+          </a:p>
+        </p:txBody>
+      </p:sp>
+    </p:spTree>
+  </p:cSld>
+  <p:clrMapOvr>
+    <a:masterClrMapping/>
+  </p:clrMapOvr>
+</p:sld>
+</file>
+
+<file path=ppt/slides/slide14.xml><?xml version="1.0" encoding="utf-8"?>
 <p:sld xmlns:a="http://schemas.openxmlformats.org/drawingml/2006/main" xmlns:p="http://schemas.openxmlformats.org/presentationml/2006/main" xmlns:r="http://schemas.openxmlformats.org/officeDocument/2006/relationships">
   <p:cSld>
     <p:bg>

</xml_diff>